<commit_message>
Actualizar presentaciones días 4, 5 y 7, eliminar día 6 y añadir ejemplos
- Actualizar presentaciones de los días 4, 5 y 7
- Eliminar presentación del día 6
- Añadir backup OLD_día_5.pptx
- Añadir directorio de ejemplos con texto de apoyo

Co-Authored-By: Claude Opus 4.6 (1M context) <noreply@anthropic.com>
</commit_message>
<xml_diff>
--- a/docs/slides/día_7.pptx
+++ b/docs/slides/día_7.pptx
@@ -7,6 +7,8 @@
   <p:sldIdLst>
     <p:sldId id="527" r:id="rId2"/>
     <p:sldId id="528" r:id="rId3"/>
+    <p:sldId id="529" r:id="rId4"/>
+    <p:sldId id="530" r:id="rId5"/>
   </p:sldIdLst>
   <p:sldSz cx="12192000" cy="6858000"/>
   <p:notesSz cx="6858000" cy="9144000"/>
@@ -105,6 +107,11 @@
       </a:defRPr>
     </a:lvl9pPr>
   </p:defaultTextStyle>
+  <p:extLst>
+    <p:ext uri="{EFAFB233-063F-42B5-8137-9DF3F51BA10A}">
+      <p15:sldGuideLst xmlns:p15="http://schemas.microsoft.com/office/powerpoint/2012/main"/>
+    </p:ext>
+  </p:extLst>
 </p:presentation>
 </file>
 
@@ -255,7 +262,7 @@
           <a:p>
             <a:fld id="{29966772-983A-4876-B405-582A5C2BC421}" type="datetimeFigureOut">
               <a:rPr lang="es-ES" smtClean="0"/>
-              <a:t>18/03/2026</a:t>
+              <a:t>19/03/2026</a:t>
             </a:fld>
             <a:endParaRPr lang="es-ES"/>
           </a:p>
@@ -453,7 +460,7 @@
           <a:p>
             <a:fld id="{29966772-983A-4876-B405-582A5C2BC421}" type="datetimeFigureOut">
               <a:rPr lang="es-ES" smtClean="0"/>
-              <a:t>18/03/2026</a:t>
+              <a:t>19/03/2026</a:t>
             </a:fld>
             <a:endParaRPr lang="es-ES"/>
           </a:p>
@@ -661,7 +668,7 @@
           <a:p>
             <a:fld id="{29966772-983A-4876-B405-582A5C2BC421}" type="datetimeFigureOut">
               <a:rPr lang="es-ES" smtClean="0"/>
-              <a:t>18/03/2026</a:t>
+              <a:t>19/03/2026</a:t>
             </a:fld>
             <a:endParaRPr lang="es-ES"/>
           </a:p>
@@ -859,7 +866,7 @@
           <a:p>
             <a:fld id="{29966772-983A-4876-B405-582A5C2BC421}" type="datetimeFigureOut">
               <a:rPr lang="es-ES" smtClean="0"/>
-              <a:t>18/03/2026</a:t>
+              <a:t>19/03/2026</a:t>
             </a:fld>
             <a:endParaRPr lang="es-ES"/>
           </a:p>
@@ -1134,7 +1141,7 @@
           <a:p>
             <a:fld id="{29966772-983A-4876-B405-582A5C2BC421}" type="datetimeFigureOut">
               <a:rPr lang="es-ES" smtClean="0"/>
-              <a:t>18/03/2026</a:t>
+              <a:t>19/03/2026</a:t>
             </a:fld>
             <a:endParaRPr lang="es-ES"/>
           </a:p>
@@ -1399,7 +1406,7 @@
           <a:p>
             <a:fld id="{29966772-983A-4876-B405-582A5C2BC421}" type="datetimeFigureOut">
               <a:rPr lang="es-ES" smtClean="0"/>
-              <a:t>18/03/2026</a:t>
+              <a:t>19/03/2026</a:t>
             </a:fld>
             <a:endParaRPr lang="es-ES"/>
           </a:p>
@@ -1811,7 +1818,7 @@
           <a:p>
             <a:fld id="{29966772-983A-4876-B405-582A5C2BC421}" type="datetimeFigureOut">
               <a:rPr lang="es-ES" smtClean="0"/>
-              <a:t>18/03/2026</a:t>
+              <a:t>19/03/2026</a:t>
             </a:fld>
             <a:endParaRPr lang="es-ES"/>
           </a:p>
@@ -1952,7 +1959,7 @@
           <a:p>
             <a:fld id="{29966772-983A-4876-B405-582A5C2BC421}" type="datetimeFigureOut">
               <a:rPr lang="es-ES" smtClean="0"/>
-              <a:t>18/03/2026</a:t>
+              <a:t>19/03/2026</a:t>
             </a:fld>
             <a:endParaRPr lang="es-ES"/>
           </a:p>
@@ -2065,7 +2072,7 @@
           <a:p>
             <a:fld id="{29966772-983A-4876-B405-582A5C2BC421}" type="datetimeFigureOut">
               <a:rPr lang="es-ES" smtClean="0"/>
-              <a:t>18/03/2026</a:t>
+              <a:t>19/03/2026</a:t>
             </a:fld>
             <a:endParaRPr lang="es-ES"/>
           </a:p>
@@ -2376,7 +2383,7 @@
           <a:p>
             <a:fld id="{29966772-983A-4876-B405-582A5C2BC421}" type="datetimeFigureOut">
               <a:rPr lang="es-ES" smtClean="0"/>
-              <a:t>18/03/2026</a:t>
+              <a:t>19/03/2026</a:t>
             </a:fld>
             <a:endParaRPr lang="es-ES"/>
           </a:p>
@@ -2664,7 +2671,7 @@
           <a:p>
             <a:fld id="{29966772-983A-4876-B405-582A5C2BC421}" type="datetimeFigureOut">
               <a:rPr lang="es-ES" smtClean="0"/>
-              <a:t>18/03/2026</a:t>
+              <a:t>19/03/2026</a:t>
             </a:fld>
             <a:endParaRPr lang="es-ES"/>
           </a:p>
@@ -2905,7 +2912,7 @@
           <a:p>
             <a:fld id="{29966772-983A-4876-B405-582A5C2BC421}" type="datetimeFigureOut">
               <a:rPr lang="es-ES" smtClean="0"/>
-              <a:t>18/03/2026</a:t>
+              <a:t>19/03/2026</a:t>
             </a:fld>
             <a:endParaRPr lang="es-ES"/>
           </a:p>
@@ -3773,6 +3780,245 @@
 </p:sld>
 </file>
 
+<file path=ppt/slides/slide3.xml><?xml version="1.0" encoding="utf-8"?>
+<p:sld xmlns:a="http://schemas.openxmlformats.org/drawingml/2006/main" xmlns:r="http://schemas.openxmlformats.org/officeDocument/2006/relationships" xmlns:p="http://schemas.openxmlformats.org/presentationml/2006/main">
+  <p:cSld>
+    <p:spTree>
+      <p:nvGrpSpPr>
+        <p:cNvPr id="1" name="">
+          <a:extLst>
+            <a:ext uri="{FF2B5EF4-FFF2-40B4-BE49-F238E27FC236}">
+              <a16:creationId xmlns:a16="http://schemas.microsoft.com/office/drawing/2014/main" id="{883DA3A6-686D-DCF2-C916-B27BA85B38E2}"/>
+            </a:ext>
+          </a:extLst>
+        </p:cNvPr>
+        <p:cNvGrpSpPr/>
+        <p:nvPr/>
+      </p:nvGrpSpPr>
+      <p:grpSpPr>
+        <a:xfrm>
+          <a:off x="0" y="0"/>
+          <a:ext cx="0" cy="0"/>
+          <a:chOff x="0" y="0"/>
+          <a:chExt cx="0" cy="0"/>
+        </a:xfrm>
+      </p:grpSpPr>
+      <p:sp>
+        <p:nvSpPr>
+          <p:cNvPr id="2" name="Título 1">
+            <a:extLst>
+              <a:ext uri="{FF2B5EF4-FFF2-40B4-BE49-F238E27FC236}">
+                <a16:creationId xmlns:a16="http://schemas.microsoft.com/office/drawing/2014/main" id="{293F3E6C-0E0C-4BFE-6465-41CFDC5F9CDC}"/>
+              </a:ext>
+            </a:extLst>
+          </p:cNvPr>
+          <p:cNvSpPr>
+            <a:spLocks noGrp="1"/>
+          </p:cNvSpPr>
+          <p:nvPr>
+            <p:ph type="title"/>
+          </p:nvPr>
+        </p:nvSpPr>
+        <p:spPr/>
+        <p:txBody>
+          <a:bodyPr/>
+          <a:lstStyle/>
+          <a:p>
+            <a:r>
+              <a:rPr lang="es-ES" b="1" dirty="0"/>
+              <a:t>Carencias de </a:t>
+            </a:r>
+            <a:r>
+              <a:rPr lang="es-ES" b="1"/>
+              <a:t>Blockchain</a:t>
+            </a:r>
+            <a:endParaRPr lang="es-ES" b="1" dirty="0"/>
+          </a:p>
+        </p:txBody>
+      </p:sp>
+      <p:pic>
+        <p:nvPicPr>
+          <p:cNvPr id="3" name="Picture 2" descr="What is the blockchain trilemma? - Electra Protocol">
+            <a:extLst>
+              <a:ext uri="{FF2B5EF4-FFF2-40B4-BE49-F238E27FC236}">
+                <a16:creationId xmlns:a16="http://schemas.microsoft.com/office/drawing/2014/main" id="{1C2FCDB3-06EF-E05F-9BE0-66F4B791C346}"/>
+              </a:ext>
+            </a:extLst>
+          </p:cNvPr>
+          <p:cNvPicPr>
+            <a:picLocks noGrp="1" noChangeAspect="1" noChangeArrowheads="1"/>
+          </p:cNvPicPr>
+          <p:nvPr>
+            <p:ph idx="1"/>
+          </p:nvPr>
+        </p:nvPicPr>
+        <p:blipFill>
+          <a:blip r:embed="rId2">
+            <a:extLst>
+              <a:ext uri="{28A0092B-C50C-407E-A947-70E740481C1C}">
+                <a14:useLocalDpi xmlns:a14="http://schemas.microsoft.com/office/drawing/2010/main" val="0"/>
+              </a:ext>
+            </a:extLst>
+          </a:blip>
+          <a:srcRect/>
+          <a:stretch>
+            <a:fillRect/>
+          </a:stretch>
+        </p:blipFill>
+        <p:spPr bwMode="auto">
+          <a:xfrm>
+            <a:off x="-254628" y="1813352"/>
+            <a:ext cx="7240163" cy="4351338"/>
+          </a:xfrm>
+          <a:prstGeom prst="rect">
+            <a:avLst/>
+          </a:prstGeom>
+          <a:noFill/>
+          <a:extLst>
+            <a:ext uri="{909E8E84-426E-40DD-AFC4-6F175D3DCCD1}">
+              <a14:hiddenFill xmlns:a14="http://schemas.microsoft.com/office/drawing/2010/main">
+                <a:solidFill>
+                  <a:srgbClr val="FFFFFF"/>
+                </a:solidFill>
+              </a14:hiddenFill>
+            </a:ext>
+          </a:extLst>
+        </p:spPr>
+      </p:pic>
+    </p:spTree>
+    <p:extLst>
+      <p:ext uri="{BB962C8B-B14F-4D97-AF65-F5344CB8AC3E}">
+        <p14:creationId xmlns:p14="http://schemas.microsoft.com/office/powerpoint/2010/main" val="918587500"/>
+      </p:ext>
+    </p:extLst>
+  </p:cSld>
+  <p:clrMapOvr>
+    <a:masterClrMapping/>
+  </p:clrMapOvr>
+</p:sld>
+</file>
+
+<file path=ppt/slides/slide4.xml><?xml version="1.0" encoding="utf-8"?>
+<p:sld xmlns:a="http://schemas.openxmlformats.org/drawingml/2006/main" xmlns:r="http://schemas.openxmlformats.org/officeDocument/2006/relationships" xmlns:p="http://schemas.openxmlformats.org/presentationml/2006/main">
+  <p:cSld>
+    <p:spTree>
+      <p:nvGrpSpPr>
+        <p:cNvPr id="1" name="">
+          <a:extLst>
+            <a:ext uri="{FF2B5EF4-FFF2-40B4-BE49-F238E27FC236}">
+              <a16:creationId xmlns:a16="http://schemas.microsoft.com/office/drawing/2014/main" id="{56E60318-854F-EA47-35E8-9A9D3BD83576}"/>
+            </a:ext>
+          </a:extLst>
+        </p:cNvPr>
+        <p:cNvGrpSpPr/>
+        <p:nvPr/>
+      </p:nvGrpSpPr>
+      <p:grpSpPr>
+        <a:xfrm>
+          <a:off x="0" y="0"/>
+          <a:ext cx="0" cy="0"/>
+          <a:chOff x="0" y="0"/>
+          <a:chExt cx="0" cy="0"/>
+        </a:xfrm>
+      </p:grpSpPr>
+      <p:sp>
+        <p:nvSpPr>
+          <p:cNvPr id="2" name="Título 1">
+            <a:extLst>
+              <a:ext uri="{FF2B5EF4-FFF2-40B4-BE49-F238E27FC236}">
+                <a16:creationId xmlns:a16="http://schemas.microsoft.com/office/drawing/2014/main" id="{A9FB6752-FE7A-B76A-CA80-6F023F0A21EE}"/>
+              </a:ext>
+            </a:extLst>
+          </p:cNvPr>
+          <p:cNvSpPr>
+            <a:spLocks noGrp="1"/>
+          </p:cNvSpPr>
+          <p:nvPr>
+            <p:ph type="title"/>
+          </p:nvPr>
+        </p:nvSpPr>
+        <p:spPr/>
+        <p:txBody>
+          <a:bodyPr/>
+          <a:lstStyle/>
+          <a:p>
+            <a:r>
+              <a:rPr lang="es-ES" b="1" dirty="0"/>
+              <a:t>El </a:t>
+            </a:r>
+            <a:r>
+              <a:rPr lang="es-ES" b="1" dirty="0" err="1"/>
+              <a:t>trilema</a:t>
+            </a:r>
+            <a:r>
+              <a:rPr lang="es-ES" b="1" dirty="0"/>
+              <a:t> revisitado</a:t>
+            </a:r>
+          </a:p>
+        </p:txBody>
+      </p:sp>
+      <p:pic>
+        <p:nvPicPr>
+          <p:cNvPr id="3" name="Picture 2" descr="What is the blockchain trilemma? - Electra Protocol">
+            <a:extLst>
+              <a:ext uri="{FF2B5EF4-FFF2-40B4-BE49-F238E27FC236}">
+                <a16:creationId xmlns:a16="http://schemas.microsoft.com/office/drawing/2014/main" id="{5A0A5303-5522-6713-A275-14214B5F491A}"/>
+              </a:ext>
+            </a:extLst>
+          </p:cNvPr>
+          <p:cNvPicPr>
+            <a:picLocks noGrp="1" noChangeAspect="1" noChangeArrowheads="1"/>
+          </p:cNvPicPr>
+          <p:nvPr>
+            <p:ph idx="1"/>
+          </p:nvPr>
+        </p:nvPicPr>
+        <p:blipFill>
+          <a:blip r:embed="rId2">
+            <a:extLst>
+              <a:ext uri="{28A0092B-C50C-407E-A947-70E740481C1C}">
+                <a14:useLocalDpi xmlns:a14="http://schemas.microsoft.com/office/drawing/2010/main" val="0"/>
+              </a:ext>
+            </a:extLst>
+          </a:blip>
+          <a:srcRect/>
+          <a:stretch>
+            <a:fillRect/>
+          </a:stretch>
+        </p:blipFill>
+        <p:spPr bwMode="auto">
+          <a:xfrm>
+            <a:off x="-254628" y="1813352"/>
+            <a:ext cx="7240163" cy="4351338"/>
+          </a:xfrm>
+          <a:prstGeom prst="rect">
+            <a:avLst/>
+          </a:prstGeom>
+          <a:noFill/>
+          <a:extLst>
+            <a:ext uri="{909E8E84-426E-40DD-AFC4-6F175D3DCCD1}">
+              <a14:hiddenFill xmlns:a14="http://schemas.microsoft.com/office/drawing/2010/main">
+                <a:solidFill>
+                  <a:srgbClr val="FFFFFF"/>
+                </a:solidFill>
+              </a14:hiddenFill>
+            </a:ext>
+          </a:extLst>
+        </p:spPr>
+      </p:pic>
+    </p:spTree>
+    <p:extLst>
+      <p:ext uri="{BB962C8B-B14F-4D97-AF65-F5344CB8AC3E}">
+        <p14:creationId xmlns:p14="http://schemas.microsoft.com/office/powerpoint/2010/main" val="1617223408"/>
+      </p:ext>
+    </p:extLst>
+  </p:cSld>
+  <p:clrMapOvr>
+    <a:masterClrMapping/>
+  </p:clrMapOvr>
+</p:sld>
+</file>
+
 <file path=ppt/theme/theme1.xml><?xml version="1.0" encoding="utf-8"?>
 <a:theme xmlns:a="http://schemas.openxmlformats.org/drawingml/2006/main" name="Tema de Office">
   <a:themeElements>

</xml_diff>